<commit_message>
Let chart label font size be changed in PowerPoint (series-level font)
Co-Authored-By: Claude Opus 5.5 <noreply@anthropic.com>
Claude-Session: https://claude.ai/code/session_01Cx9kswyecF7JAB1Rr5vVcV
</commit_message>
<xml_diff>
--- a/nedp_deck/McK_3bar_Units_Value_Share.pptx
+++ b/nedp_deck/McK_3bar_Units_Value_Share.pptx
@@ -149,22 +149,20 @@
                   <a:lstStyle/>
                   <a:p>
                     <a:r>
-                      <a:rPr sz="1300" b="1">
+                      <a:rPr>
                         <a:solidFill>
                           <a:srgbClr val="000000"/>
                         </a:solidFill>
-                        <a:latin typeface="Neue Haas Grotesk Text Pro"/>
                       </a:rPr>
                       <a:t>177 units</a:t>
                     </a:r>
                   </a:p>
                   <a:p>
                     <a:r>
-                      <a:rPr sz="1300" b="1">
+                      <a:rPr>
                         <a:solidFill>
                           <a:srgbClr val="000000"/>
                         </a:solidFill>
-                        <a:latin typeface="Neue Haas Grotesk Text Pro"/>
                       </a:rPr>
                       <a:t>28%</a:t>
                     </a:r>
@@ -186,22 +184,20 @@
                   <a:lstStyle/>
                   <a:p>
                     <a:r>
-                      <a:rPr sz="1300" b="1">
+                      <a:rPr>
                         <a:solidFill>
                           <a:srgbClr val="000000"/>
                         </a:solidFill>
-                        <a:latin typeface="Neue Haas Grotesk Text Pro"/>
                       </a:rPr>
                       <a:t>Rp 40,1 B</a:t>
                     </a:r>
                   </a:p>
                   <a:p>
                     <a:r>
-                      <a:rPr sz="1300" b="1">
+                      <a:rPr>
                         <a:solidFill>
                           <a:srgbClr val="000000"/>
                         </a:solidFill>
-                        <a:latin typeface="Neue Haas Grotesk Text Pro"/>
                       </a:rPr>
                       <a:t>12%</a:t>
                     </a:r>
@@ -223,11 +219,10 @@
                   <a:lstStyle/>
                   <a:p>
                     <a:r>
-                      <a:rPr sz="1300" b="1">
+                      <a:rPr>
                         <a:solidFill>
                           <a:srgbClr val="000000"/>
                         </a:solidFill>
-                        <a:latin typeface="Neue Haas Grotesk Text Pro"/>
                       </a:rPr>
                       <a:t>28% → 12%</a:t>
                     </a:r>
@@ -241,6 +236,17 @@
               <c:showPercent val="0"/>
               <c:showBubbleSize val="0"/>
             </c:dLbl>
+            <c:txPr>
+              <a:bodyPr/>
+              <a:lstStyle/>
+              <a:p>
+                <a:pPr>
+                  <a:defRPr sz="1300" b="1">
+                    <a:latin typeface="Neue Haas Grotesk Text Pro"/>
+                  </a:defRPr>
+                </a:pPr>
+              </a:p>
+            </c:txPr>
             <c:showLegendKey val="0"/>
             <c:showVal val="0"/>
             <c:showCatName val="0"/>
@@ -318,22 +324,20 @@
                   <a:lstStyle/>
                   <a:p>
                     <a:r>
-                      <a:rPr sz="1300" b="1">
+                      <a:rPr>
                         <a:solidFill>
                           <a:srgbClr val="000000"/>
                         </a:solidFill>
-                        <a:latin typeface="Neue Haas Grotesk Text Pro"/>
                       </a:rPr>
                       <a:t>200 units</a:t>
                     </a:r>
                   </a:p>
                   <a:p>
                     <a:r>
-                      <a:rPr sz="1300" b="1">
+                      <a:rPr>
                         <a:solidFill>
                           <a:srgbClr val="000000"/>
                         </a:solidFill>
-                        <a:latin typeface="Neue Haas Grotesk Text Pro"/>
                       </a:rPr>
                       <a:t>31%</a:t>
                     </a:r>
@@ -355,22 +359,20 @@
                   <a:lstStyle/>
                   <a:p>
                     <a:r>
-                      <a:rPr sz="1300" b="1">
+                      <a:rPr>
                         <a:solidFill>
                           <a:srgbClr val="000000"/>
                         </a:solidFill>
-                        <a:latin typeface="Neue Haas Grotesk Text Pro"/>
                       </a:rPr>
                       <a:t>Rp 77,2 B</a:t>
                     </a:r>
                   </a:p>
                   <a:p>
                     <a:r>
-                      <a:rPr sz="1300" b="1">
+                      <a:rPr>
                         <a:solidFill>
                           <a:srgbClr val="000000"/>
                         </a:solidFill>
-                        <a:latin typeface="Neue Haas Grotesk Text Pro"/>
                       </a:rPr>
                       <a:t>24%</a:t>
                     </a:r>
@@ -392,11 +394,10 @@
                   <a:lstStyle/>
                   <a:p>
                     <a:r>
-                      <a:rPr sz="1300" b="1">
+                      <a:rPr>
                         <a:solidFill>
                           <a:srgbClr val="000000"/>
                         </a:solidFill>
-                        <a:latin typeface="Neue Haas Grotesk Text Pro"/>
                       </a:rPr>
                       <a:t>31% → 24%</a:t>
                     </a:r>
@@ -410,6 +411,17 @@
               <c:showPercent val="0"/>
               <c:showBubbleSize val="0"/>
             </c:dLbl>
+            <c:txPr>
+              <a:bodyPr/>
+              <a:lstStyle/>
+              <a:p>
+                <a:pPr>
+                  <a:defRPr sz="1300" b="1">
+                    <a:latin typeface="Neue Haas Grotesk Text Pro"/>
+                  </a:defRPr>
+                </a:pPr>
+              </a:p>
+            </c:txPr>
             <c:showLegendKey val="0"/>
             <c:showVal val="0"/>
             <c:showCatName val="0"/>
@@ -487,22 +499,20 @@
                   <a:lstStyle/>
                   <a:p>
                     <a:r>
-                      <a:rPr sz="1300" b="1">
+                      <a:rPr>
                         <a:solidFill>
                           <a:srgbClr val="FFFFFF"/>
                         </a:solidFill>
-                        <a:latin typeface="Neue Haas Grotesk Text Pro"/>
                       </a:rPr>
                       <a:t>196 units</a:t>
                     </a:r>
                   </a:p>
                   <a:p>
                     <a:r>
-                      <a:rPr sz="1300" b="1">
+                      <a:rPr>
                         <a:solidFill>
                           <a:srgbClr val="FFFFFF"/>
                         </a:solidFill>
-                        <a:latin typeface="Neue Haas Grotesk Text Pro"/>
                       </a:rPr>
                       <a:t>31%</a:t>
                     </a:r>
@@ -524,22 +534,20 @@
                   <a:lstStyle/>
                   <a:p>
                     <a:r>
-                      <a:rPr sz="1300" b="1">
+                      <a:rPr>
                         <a:solidFill>
                           <a:srgbClr val="FFFFFF"/>
                         </a:solidFill>
-                        <a:latin typeface="Neue Haas Grotesk Text Pro"/>
                       </a:rPr>
                       <a:t>Rp 118,3 B</a:t>
                     </a:r>
                   </a:p>
                   <a:p>
                     <a:r>
-                      <a:rPr sz="1300" b="1">
+                      <a:rPr>
                         <a:solidFill>
                           <a:srgbClr val="FFFFFF"/>
                         </a:solidFill>
-                        <a:latin typeface="Neue Haas Grotesk Text Pro"/>
                       </a:rPr>
                       <a:t>36%</a:t>
                     </a:r>
@@ -561,11 +569,10 @@
                   <a:lstStyle/>
                   <a:p>
                     <a:r>
-                      <a:rPr sz="1300" b="1">
+                      <a:rPr>
                         <a:solidFill>
                           <a:srgbClr val="FFFFFF"/>
                         </a:solidFill>
-                        <a:latin typeface="Neue Haas Grotesk Text Pro"/>
                       </a:rPr>
                       <a:t>31% → 36%</a:t>
                     </a:r>
@@ -579,6 +586,17 @@
               <c:showPercent val="0"/>
               <c:showBubbleSize val="0"/>
             </c:dLbl>
+            <c:txPr>
+              <a:bodyPr/>
+              <a:lstStyle/>
+              <a:p>
+                <a:pPr>
+                  <a:defRPr sz="1300" b="1">
+                    <a:latin typeface="Neue Haas Grotesk Text Pro"/>
+                  </a:defRPr>
+                </a:pPr>
+              </a:p>
+            </c:txPr>
             <c:showLegendKey val="0"/>
             <c:showVal val="0"/>
             <c:showCatName val="0"/>
@@ -656,22 +674,20 @@
                   <a:lstStyle/>
                   <a:p>
                     <a:r>
-                      <a:rPr sz="1300" b="1">
+                      <a:rPr>
                         <a:solidFill>
                           <a:srgbClr val="FFFFFF"/>
                         </a:solidFill>
-                        <a:latin typeface="Neue Haas Grotesk Text Pro"/>
                       </a:rPr>
                       <a:t>65 units</a:t>
                     </a:r>
                   </a:p>
                   <a:p>
                     <a:r>
-                      <a:rPr sz="1300" b="1">
+                      <a:rPr>
                         <a:solidFill>
                           <a:srgbClr val="FFFFFF"/>
                         </a:solidFill>
-                        <a:latin typeface="Neue Haas Grotesk Text Pro"/>
                       </a:rPr>
                       <a:t>10%</a:t>
                     </a:r>
@@ -693,22 +709,20 @@
                   <a:lstStyle/>
                   <a:p>
                     <a:r>
-                      <a:rPr sz="1300" b="1">
+                      <a:rPr>
                         <a:solidFill>
                           <a:srgbClr val="FFFFFF"/>
                         </a:solidFill>
-                        <a:latin typeface="Neue Haas Grotesk Text Pro"/>
                       </a:rPr>
                       <a:t>Rp 91,2 B</a:t>
                     </a:r>
                   </a:p>
                   <a:p>
                     <a:r>
-                      <a:rPr sz="1300" b="1">
+                      <a:rPr>
                         <a:solidFill>
                           <a:srgbClr val="FFFFFF"/>
                         </a:solidFill>
-                        <a:latin typeface="Neue Haas Grotesk Text Pro"/>
                       </a:rPr>
                       <a:t>28%</a:t>
                     </a:r>
@@ -730,11 +744,10 @@
                   <a:lstStyle/>
                   <a:p>
                     <a:r>
-                      <a:rPr sz="1300" b="1">
+                      <a:rPr>
                         <a:solidFill>
                           <a:srgbClr val="FFFFFF"/>
                         </a:solidFill>
-                        <a:latin typeface="Neue Haas Grotesk Text Pro"/>
                       </a:rPr>
                       <a:t>10% → 28%</a:t>
                     </a:r>
@@ -748,6 +761,17 @@
               <c:showPercent val="0"/>
               <c:showBubbleSize val="0"/>
             </c:dLbl>
+            <c:txPr>
+              <a:bodyPr/>
+              <a:lstStyle/>
+              <a:p>
+                <a:pPr>
+                  <a:defRPr sz="1300" b="1">
+                    <a:latin typeface="Neue Haas Grotesk Text Pro"/>
+                  </a:defRPr>
+                </a:pPr>
+              </a:p>
+            </c:txPr>
             <c:showLegendKey val="0"/>
             <c:showVal val="0"/>
             <c:showCatName val="0"/>

</xml_diff>

<commit_message>
Keep chart labels bold
Co-Authored-By: Claude Opus 5.5 <noreply@anthropic.com>
Claude-Session: https://claude.ai/code/session_01Cx9kswyecF7JAB1Rr5vVcV
</commit_message>
<xml_diff>
--- a/nedp_deck/McK_3bar_Units_Value_Share.pptx
+++ b/nedp_deck/McK_3bar_Units_Value_Share.pptx
@@ -149,7 +149,7 @@
                   <a:lstStyle/>
                   <a:p>
                     <a:r>
-                      <a:rPr>
+                      <a:rPr b="1">
                         <a:solidFill>
                           <a:srgbClr val="000000"/>
                         </a:solidFill>
@@ -159,7 +159,7 @@
                   </a:p>
                   <a:p>
                     <a:r>
-                      <a:rPr>
+                      <a:rPr b="1">
                         <a:solidFill>
                           <a:srgbClr val="000000"/>
                         </a:solidFill>
@@ -184,7 +184,7 @@
                   <a:lstStyle/>
                   <a:p>
                     <a:r>
-                      <a:rPr>
+                      <a:rPr b="1">
                         <a:solidFill>
                           <a:srgbClr val="000000"/>
                         </a:solidFill>
@@ -194,7 +194,7 @@
                   </a:p>
                   <a:p>
                     <a:r>
-                      <a:rPr>
+                      <a:rPr b="1">
                         <a:solidFill>
                           <a:srgbClr val="000000"/>
                         </a:solidFill>
@@ -219,7 +219,7 @@
                   <a:lstStyle/>
                   <a:p>
                     <a:r>
-                      <a:rPr>
+                      <a:rPr b="1">
                         <a:solidFill>
                           <a:srgbClr val="000000"/>
                         </a:solidFill>
@@ -324,7 +324,7 @@
                   <a:lstStyle/>
                   <a:p>
                     <a:r>
-                      <a:rPr>
+                      <a:rPr b="1">
                         <a:solidFill>
                           <a:srgbClr val="000000"/>
                         </a:solidFill>
@@ -334,7 +334,7 @@
                   </a:p>
                   <a:p>
                     <a:r>
-                      <a:rPr>
+                      <a:rPr b="1">
                         <a:solidFill>
                           <a:srgbClr val="000000"/>
                         </a:solidFill>
@@ -359,7 +359,7 @@
                   <a:lstStyle/>
                   <a:p>
                     <a:r>
-                      <a:rPr>
+                      <a:rPr b="1">
                         <a:solidFill>
                           <a:srgbClr val="000000"/>
                         </a:solidFill>
@@ -369,7 +369,7 @@
                   </a:p>
                   <a:p>
                     <a:r>
-                      <a:rPr>
+                      <a:rPr b="1">
                         <a:solidFill>
                           <a:srgbClr val="000000"/>
                         </a:solidFill>
@@ -394,7 +394,7 @@
                   <a:lstStyle/>
                   <a:p>
                     <a:r>
-                      <a:rPr>
+                      <a:rPr b="1">
                         <a:solidFill>
                           <a:srgbClr val="000000"/>
                         </a:solidFill>
@@ -499,7 +499,7 @@
                   <a:lstStyle/>
                   <a:p>
                     <a:r>
-                      <a:rPr>
+                      <a:rPr b="1">
                         <a:solidFill>
                           <a:srgbClr val="FFFFFF"/>
                         </a:solidFill>
@@ -509,7 +509,7 @@
                   </a:p>
                   <a:p>
                     <a:r>
-                      <a:rPr>
+                      <a:rPr b="1">
                         <a:solidFill>
                           <a:srgbClr val="FFFFFF"/>
                         </a:solidFill>
@@ -534,7 +534,7 @@
                   <a:lstStyle/>
                   <a:p>
                     <a:r>
-                      <a:rPr>
+                      <a:rPr b="1">
                         <a:solidFill>
                           <a:srgbClr val="FFFFFF"/>
                         </a:solidFill>
@@ -544,7 +544,7 @@
                   </a:p>
                   <a:p>
                     <a:r>
-                      <a:rPr>
+                      <a:rPr b="1">
                         <a:solidFill>
                           <a:srgbClr val="FFFFFF"/>
                         </a:solidFill>
@@ -569,7 +569,7 @@
                   <a:lstStyle/>
                   <a:p>
                     <a:r>
-                      <a:rPr>
+                      <a:rPr b="1">
                         <a:solidFill>
                           <a:srgbClr val="FFFFFF"/>
                         </a:solidFill>
@@ -674,7 +674,7 @@
                   <a:lstStyle/>
                   <a:p>
                     <a:r>
-                      <a:rPr>
+                      <a:rPr b="1">
                         <a:solidFill>
                           <a:srgbClr val="FFFFFF"/>
                         </a:solidFill>
@@ -684,7 +684,7 @@
                   </a:p>
                   <a:p>
                     <a:r>
-                      <a:rPr>
+                      <a:rPr b="1">
                         <a:solidFill>
                           <a:srgbClr val="FFFFFF"/>
                         </a:solidFill>
@@ -709,7 +709,7 @@
                   <a:lstStyle/>
                   <a:p>
                     <a:r>
-                      <a:rPr>
+                      <a:rPr b="1">
                         <a:solidFill>
                           <a:srgbClr val="FFFFFF"/>
                         </a:solidFill>
@@ -719,7 +719,7 @@
                   </a:p>
                   <a:p>
                     <a:r>
-                      <a:rPr>
+                      <a:rPr b="1">
                         <a:solidFill>
                           <a:srgbClr val="FFFFFF"/>
                         </a:solidFill>
@@ -744,7 +744,7 @@
                   <a:lstStyle/>
                   <a:p>
                     <a:r>
-                      <a:rPr>
+                      <a:rPr b="1">
                         <a:solidFill>
                           <a:srgbClr val="FFFFFF"/>
                         </a:solidFill>

</xml_diff>

<commit_message>
Use database figures (764 units, USD value) in 3-bar chart
Co-Authored-By: Claude Opus 5.5 <noreply@anthropic.com>
Claude-Session: https://claude.ai/code/session_01Cx9kswyecF7JAB1Rr5vVcV
</commit_message>
<xml_diff>
--- a/nedp_deck/McK_3bar_Units_Value_Share.pptx
+++ b/nedp_deck/McK_3bar_Units_Value_Share.pptx
@@ -154,7 +154,7 @@
                           <a:srgbClr val="000000"/>
                         </a:solidFill>
                       </a:rPr>
-                      <a:t>177 units</a:t>
+                      <a:t>248 units</a:t>
                     </a:r>
                   </a:p>
                   <a:p>
@@ -164,7 +164,7 @@
                           <a:srgbClr val="000000"/>
                         </a:solidFill>
                       </a:rPr>
-                      <a:t>28%</a:t>
+                      <a:t>32%</a:t>
                     </a:r>
                   </a:p>
                 </c:rich>
@@ -189,7 +189,7 @@
                           <a:srgbClr val="000000"/>
                         </a:solidFill>
                       </a:rPr>
-                      <a:t>Rp 40,1 B</a:t>
+                      <a:t>$3,02 M</a:t>
                     </a:r>
                   </a:p>
                   <a:p>
@@ -199,7 +199,7 @@
                           <a:srgbClr val="000000"/>
                         </a:solidFill>
                       </a:rPr>
-                      <a:t>12%</a:t>
+                      <a:t>14%</a:t>
                     </a:r>
                   </a:p>
                 </c:rich>
@@ -224,7 +224,7 @@
                           <a:srgbClr val="000000"/>
                         </a:solidFill>
                       </a:rPr>
-                      <a:t>28% → 12%</a:t>
+                      <a:t>32% → 14%</a:t>
                     </a:r>
                   </a:p>
                 </c:rich>
@@ -264,7 +264,7 @@
                   <c:v>Units (qty)</c:v>
                 </c:pt>
                 <c:pt idx="1">
-                  <c:v>Value (IDR)</c:v>
+                  <c:v>Value (USD)</c:v>
                 </c:pt>
                 <c:pt idx="2">
                   <c:v>Share (units → value)</c:v>
@@ -279,13 +279,13 @@
                 <c:formatCode>General</c:formatCode>
                 <c:ptCount val="3"/>
                 <c:pt idx="0">
-                  <c:v>177</c:v>
+                  <c:v>248</c:v>
                 </c:pt>
                 <c:pt idx="1">
-                  <c:v>40.118</c:v>
+                  <c:v>3.019087</c:v>
                 </c:pt>
                 <c:pt idx="2">
-                  <c:v>40.118</c:v>
+                  <c:v>3.019087</c:v>
                 </c:pt>
               </c:numCache>
             </c:numRef>
@@ -329,7 +329,7 @@
                           <a:srgbClr val="000000"/>
                         </a:solidFill>
                       </a:rPr>
-                      <a:t>200 units</a:t>
+                      <a:t>223 units</a:t>
                     </a:r>
                   </a:p>
                   <a:p>
@@ -339,7 +339,7 @@
                           <a:srgbClr val="000000"/>
                         </a:solidFill>
                       </a:rPr>
-                      <a:t>31%</a:t>
+                      <a:t>29%</a:t>
                     </a:r>
                   </a:p>
                 </c:rich>
@@ -364,7 +364,7 @@
                           <a:srgbClr val="000000"/>
                         </a:solidFill>
                       </a:rPr>
-                      <a:t>Rp 77,2 B</a:t>
+                      <a:t>$5,04 M</a:t>
                     </a:r>
                   </a:p>
                   <a:p>
@@ -399,7 +399,7 @@
                           <a:srgbClr val="000000"/>
                         </a:solidFill>
                       </a:rPr>
-                      <a:t>31% → 24%</a:t>
+                      <a:t>29% → 24%</a:t>
                     </a:r>
                   </a:p>
                 </c:rich>
@@ -439,7 +439,7 @@
                   <c:v>Units (qty)</c:v>
                 </c:pt>
                 <c:pt idx="1">
-                  <c:v>Value (IDR)</c:v>
+                  <c:v>Value (USD)</c:v>
                 </c:pt>
                 <c:pt idx="2">
                   <c:v>Share (units → value)</c:v>
@@ -454,13 +454,13 @@
                 <c:formatCode>General</c:formatCode>
                 <c:ptCount val="3"/>
                 <c:pt idx="0">
-                  <c:v>200</c:v>
+                  <c:v>223</c:v>
                 </c:pt>
                 <c:pt idx="1">
-                  <c:v>77.241</c:v>
+                  <c:v>5.037297</c:v>
                 </c:pt>
                 <c:pt idx="2">
-                  <c:v>77.241</c:v>
+                  <c:v>5.037297</c:v>
                 </c:pt>
               </c:numCache>
             </c:numRef>
@@ -504,7 +504,7 @@
                           <a:srgbClr val="FFFFFF"/>
                         </a:solidFill>
                       </a:rPr>
-                      <a:t>196 units</a:t>
+                      <a:t>218 units</a:t>
                     </a:r>
                   </a:p>
                   <a:p>
@@ -514,7 +514,7 @@
                           <a:srgbClr val="FFFFFF"/>
                         </a:solidFill>
                       </a:rPr>
-                      <a:t>31%</a:t>
+                      <a:t>29%</a:t>
                     </a:r>
                   </a:p>
                 </c:rich>
@@ -539,7 +539,7 @@
                           <a:srgbClr val="FFFFFF"/>
                         </a:solidFill>
                       </a:rPr>
-                      <a:t>Rp 118,3 B</a:t>
+                      <a:t>$7,30 M</a:t>
                     </a:r>
                   </a:p>
                   <a:p>
@@ -549,7 +549,7 @@
                           <a:srgbClr val="FFFFFF"/>
                         </a:solidFill>
                       </a:rPr>
-                      <a:t>36%</a:t>
+                      <a:t>35%</a:t>
                     </a:r>
                   </a:p>
                 </c:rich>
@@ -574,7 +574,7 @@
                           <a:srgbClr val="FFFFFF"/>
                         </a:solidFill>
                       </a:rPr>
-                      <a:t>31% → 36%</a:t>
+                      <a:t>29% → 35%</a:t>
                     </a:r>
                   </a:p>
                 </c:rich>
@@ -614,7 +614,7 @@
                   <c:v>Units (qty)</c:v>
                 </c:pt>
                 <c:pt idx="1">
-                  <c:v>Value (IDR)</c:v>
+                  <c:v>Value (USD)</c:v>
                 </c:pt>
                 <c:pt idx="2">
                   <c:v>Share (units → value)</c:v>
@@ -629,13 +629,13 @@
                 <c:formatCode>General</c:formatCode>
                 <c:ptCount val="3"/>
                 <c:pt idx="0">
-                  <c:v>196</c:v>
+                  <c:v>218</c:v>
                 </c:pt>
                 <c:pt idx="1">
-                  <c:v>118.328</c:v>
+                  <c:v>7.304431</c:v>
                 </c:pt>
                 <c:pt idx="2">
-                  <c:v>118.328</c:v>
+                  <c:v>7.304431</c:v>
                 </c:pt>
               </c:numCache>
             </c:numRef>
@@ -679,7 +679,7 @@
                           <a:srgbClr val="FFFFFF"/>
                         </a:solidFill>
                       </a:rPr>
-                      <a:t>65 units</a:t>
+                      <a:t>75 units</a:t>
                     </a:r>
                   </a:p>
                   <a:p>
@@ -714,7 +714,7 @@
                           <a:srgbClr val="FFFFFF"/>
                         </a:solidFill>
                       </a:rPr>
-                      <a:t>Rp 91,2 B</a:t>
+                      <a:t>$5,71 M</a:t>
                     </a:r>
                   </a:p>
                   <a:p>
@@ -724,7 +724,7 @@
                           <a:srgbClr val="FFFFFF"/>
                         </a:solidFill>
                       </a:rPr>
-                      <a:t>28%</a:t>
+                      <a:t>27%</a:t>
                     </a:r>
                   </a:p>
                 </c:rich>
@@ -749,7 +749,7 @@
                           <a:srgbClr val="FFFFFF"/>
                         </a:solidFill>
                       </a:rPr>
-                      <a:t>10% → 28%</a:t>
+                      <a:t>10% → 27%</a:t>
                     </a:r>
                   </a:p>
                 </c:rich>
@@ -789,7 +789,7 @@
                   <c:v>Units (qty)</c:v>
                 </c:pt>
                 <c:pt idx="1">
-                  <c:v>Value (IDR)</c:v>
+                  <c:v>Value (USD)</c:v>
                 </c:pt>
                 <c:pt idx="2">
                   <c:v>Share (units → value)</c:v>
@@ -804,13 +804,13 @@
                 <c:formatCode>General</c:formatCode>
                 <c:ptCount val="3"/>
                 <c:pt idx="0">
-                  <c:v>65</c:v>
+                  <c:v>75</c:v>
                 </c:pt>
                 <c:pt idx="1">
-                  <c:v>91.154</c:v>
+                  <c:v>5.712582</c:v>
                 </c:pt>
                 <c:pt idx="2">
-                  <c:v>91.154</c:v>
+                  <c:v>5.712582</c:v>
                 </c:pt>
               </c:numCache>
             </c:numRef>
@@ -3913,7 +3913,7 @@
                 </a:solidFill>
                 <a:latin typeface="Neue Haas Grotesk Text Pro"/>
               </a:rPr>
-              <a:t>Heavy is 10% of units but 28% of value</a:t>
+              <a:t>Heavy is 10% of units but 27% of value</a:t>
             </a:r>
           </a:p>
         </p:txBody>
@@ -3947,7 +3947,7 @@
                 </a:solidFill>
                 <a:latin typeface="Neue Haas Grotesk Text Pro"/>
               </a:rPr>
-              <a:t>Crane sales by class (100% = 638 units = Rp 326,8 B)</a:t>
+              <a:t>Crane imports by class, 2023 – 2026* (100% = 764 units = $21,07 M)</a:t>
             </a:r>
           </a:p>
         </p:txBody>
@@ -3999,7 +3999,7 @@
                 </a:solidFill>
                 <a:latin typeface="Neue Haas Grotesk Text Pro"/>
               </a:rPr>
-              <a:t>Source: NEDP deck sales data; value in IDR (B = billion). Share = % of total units / % of total value.</a:t>
+              <a:t>*2026 = partial year (to Aug). Source: Indonesia import records, knuckle boom cranes; value in USD (M = million). Share = % of total units / % of total value.</a:t>
             </a:r>
           </a:p>
         </p:txBody>

</xml_diff>

<commit_message>
Show values in IDR (assumed Rp 16.000/USD) on 3-bar chart and slide 12
Co-Authored-By: Claude Opus 5.5 <noreply@anthropic.com>
Claude-Session: https://claude.ai/code/session_01Cx9kswyecF7JAB1Rr5vVcV
</commit_message>
<xml_diff>
--- a/nedp_deck/McK_3bar_Units_Value_Share.pptx
+++ b/nedp_deck/McK_3bar_Units_Value_Share.pptx
@@ -189,7 +189,7 @@
                           <a:srgbClr val="000000"/>
                         </a:solidFill>
                       </a:rPr>
-                      <a:t>$3,02 M</a:t>
+                      <a:t>Rp 48,3 Bio</a:t>
                     </a:r>
                   </a:p>
                   <a:p>
@@ -264,7 +264,7 @@
                   <c:v>Units (qty)</c:v>
                 </c:pt>
                 <c:pt idx="1">
-                  <c:v>Value (USD)</c:v>
+                  <c:v>Value (IDR)</c:v>
                 </c:pt>
                 <c:pt idx="2">
                   <c:v>Share (units → value)</c:v>
@@ -282,10 +282,10 @@
                   <c:v>248</c:v>
                 </c:pt>
                 <c:pt idx="1">
-                  <c:v>3.019087</c:v>
+                  <c:v>48.305392</c:v>
                 </c:pt>
                 <c:pt idx="2">
-                  <c:v>3.019087</c:v>
+                  <c:v>48.305392</c:v>
                 </c:pt>
               </c:numCache>
             </c:numRef>
@@ -364,7 +364,7 @@
                           <a:srgbClr val="000000"/>
                         </a:solidFill>
                       </a:rPr>
-                      <a:t>$5,04 M</a:t>
+                      <a:t>Rp 80,6 Bio</a:t>
                     </a:r>
                   </a:p>
                   <a:p>
@@ -439,7 +439,7 @@
                   <c:v>Units (qty)</c:v>
                 </c:pt>
                 <c:pt idx="1">
-                  <c:v>Value (USD)</c:v>
+                  <c:v>Value (IDR)</c:v>
                 </c:pt>
                 <c:pt idx="2">
                   <c:v>Share (units → value)</c:v>
@@ -457,10 +457,10 @@
                   <c:v>223</c:v>
                 </c:pt>
                 <c:pt idx="1">
-                  <c:v>5.037297</c:v>
+                  <c:v>80.596752</c:v>
                 </c:pt>
                 <c:pt idx="2">
-                  <c:v>5.037297</c:v>
+                  <c:v>80.596752</c:v>
                 </c:pt>
               </c:numCache>
             </c:numRef>
@@ -539,7 +539,7 @@
                           <a:srgbClr val="FFFFFF"/>
                         </a:solidFill>
                       </a:rPr>
-                      <a:t>$7,30 M</a:t>
+                      <a:t>Rp 116,9 Bio</a:t>
                     </a:r>
                   </a:p>
                   <a:p>
@@ -614,7 +614,7 @@
                   <c:v>Units (qty)</c:v>
                 </c:pt>
                 <c:pt idx="1">
-                  <c:v>Value (USD)</c:v>
+                  <c:v>Value (IDR)</c:v>
                 </c:pt>
                 <c:pt idx="2">
                   <c:v>Share (units → value)</c:v>
@@ -632,10 +632,10 @@
                   <c:v>218</c:v>
                 </c:pt>
                 <c:pt idx="1">
-                  <c:v>7.304431</c:v>
+                  <c:v>116.870896</c:v>
                 </c:pt>
                 <c:pt idx="2">
-                  <c:v>7.304431</c:v>
+                  <c:v>116.870896</c:v>
                 </c:pt>
               </c:numCache>
             </c:numRef>
@@ -714,7 +714,7 @@
                           <a:srgbClr val="FFFFFF"/>
                         </a:solidFill>
                       </a:rPr>
-                      <a:t>$5,71 M</a:t>
+                      <a:t>Rp 91,4 Bio</a:t>
                     </a:r>
                   </a:p>
                   <a:p>
@@ -789,7 +789,7 @@
                   <c:v>Units (qty)</c:v>
                 </c:pt>
                 <c:pt idx="1">
-                  <c:v>Value (USD)</c:v>
+                  <c:v>Value (IDR)</c:v>
                 </c:pt>
                 <c:pt idx="2">
                   <c:v>Share (units → value)</c:v>
@@ -807,10 +807,10 @@
                   <c:v>75</c:v>
                 </c:pt>
                 <c:pt idx="1">
-                  <c:v>5.712582</c:v>
+                  <c:v>91.401312</c:v>
                 </c:pt>
                 <c:pt idx="2">
-                  <c:v>5.712582</c:v>
+                  <c:v>91.401312</c:v>
                 </c:pt>
               </c:numCache>
             </c:numRef>
@@ -3947,7 +3947,7 @@
                 </a:solidFill>
                 <a:latin typeface="Neue Haas Grotesk Text Pro"/>
               </a:rPr>
-              <a:t>Crane imports by class, 2023 – 2026* (100% = 764 units = $21,07 M)</a:t>
+              <a:t>Crane imports by class, 2023 – 2026* (100% = 764 units = Rp 337,2 Bio)</a:t>
             </a:r>
           </a:p>
         </p:txBody>
@@ -3999,7 +3999,7 @@
                 </a:solidFill>
                 <a:latin typeface="Neue Haas Grotesk Text Pro"/>
               </a:rPr>
-              <a:t>*2026 = partial year (to Aug). Source: Indonesia import records, knuckle boom cranes; value in USD (M = million). Share = % of total units / % of total value.</a:t>
+              <a:t>*2026 = partial year (to Aug). Source: Indonesia import records, knuckle boom cranes; value converted from USD at assumed Rp 16.000/USD (Bio = billion). Share = % of total units / % of total value.</a:t>
             </a:r>
           </a:p>
         </p:txBody>

</xml_diff>